<commit_message>
feat: complete PRISM fullstack project setup with backend, frontend, and clean architecture
</commit_message>
<xml_diff>
--- a/outputs/PRISM_Presentation_test_run_01.pptx
+++ b/outputs/PRISM_Presentation_test_run_01.pptx
@@ -10,7 +10,6 @@
     <p:sldId id="258" r:id="rId9"/>
     <p:sldId id="259" r:id="rId10"/>
     <p:sldId id="260" r:id="rId11"/>
-    <p:sldId id="261" r:id="rId12"/>
   </p:sldIdLst>
   <p:sldSz cx="9144000" cy="6858000" type="screen4x3"/>
   <p:notesSz cx="6858000" cy="9144000"/>
@@ -3130,7 +3129,7 @@
           <a:lstStyle/>
           <a:p>
             <a:r>
-              <a:t>PRISM is an AI-powered content generation system.</a:t>
+              <a:t>AI-driven system for generating multiple content formats from a single source document.</a:t>
             </a:r>
           </a:p>
         </p:txBody>
@@ -3169,7 +3168,7 @@
           <a:lstStyle/>
           <a:p>
             <a:r>
-              <a:t>Key Features</a:t>
+              <a:t>Core Functionality</a:t>
             </a:r>
           </a:p>
         </p:txBody>
@@ -3194,7 +3193,7 @@
               <a:defRPr sz="2200"/>
             </a:pPr>
             <a:r>
-              <a:t>Source document input</a:t>
+              <a:t>Transforms source documents into diverse content formats.</a:t>
             </a:r>
           </a:p>
           <a:p>
@@ -3202,15 +3201,7 @@
               <a:defRPr sz="2200"/>
             </a:pPr>
             <a:r>
-              <a:t>Multiple content formats</a:t>
-            </a:r>
-          </a:p>
-          <a:p>
-            <a:pPr>
-              <a:defRPr sz="2200"/>
-            </a:pPr>
-            <a:r>
-              <a:t>Centralized Fact Graph for consistency</a:t>
+              <a:t>Centralized Fact Graph ensures consistency across outputs.</a:t>
             </a:r>
           </a:p>
         </p:txBody>
@@ -3249,7 +3240,7 @@
           <a:lstStyle/>
           <a:p>
             <a:r>
-              <a:t>Process Flow</a:t>
+              <a:t>Efficiency Gains</a:t>
             </a:r>
           </a:p>
         </p:txBody>
@@ -3274,23 +3265,7 @@
               <a:defRPr sz="2200"/>
             </a:pPr>
             <a:r>
-              <a:t>Takes source document</a:t>
-            </a:r>
-          </a:p>
-          <a:p>
-            <a:pPr>
-              <a:defRPr sz="2200"/>
-            </a:pPr>
-            <a:r>
-              <a:t>Generates multiple formats</a:t>
-            </a:r>
-          </a:p>
-          <a:p>
-            <a:pPr>
-              <a:defRPr sz="2200"/>
-            </a:pPr>
-            <a:r>
-              <a:t>Utilizes Fact Graph</a:t>
+              <a:t>Reduces multi-channel authoring time by 75%.</a:t>
             </a:r>
           </a:p>
         </p:txBody>
@@ -3329,7 +3304,7 @@
           <a:lstStyle/>
           <a:p>
             <a:r>
-              <a:t>Efficiency Gains</a:t>
+              <a:t>Data Integrity</a:t>
             </a:r>
           </a:p>
         </p:txBody>
@@ -3354,7 +3329,7 @@
               <a:defRPr sz="2200"/>
             </a:pPr>
             <a:r>
-              <a:t>Reduces multi-channel authoring time by 75%</a:t>
+              <a:t>Guarantees 100% provenance verification.</a:t>
             </a:r>
           </a:p>
         </p:txBody>
@@ -3393,7 +3368,7 @@
           <a:lstStyle/>
           <a:p>
             <a:r>
-              <a:t>Reliability</a:t>
+              <a:t>Conclusion</a:t>
             </a:r>
           </a:p>
         </p:txBody>
@@ -3418,71 +3393,7 @@
               <a:defRPr sz="2200"/>
             </a:pPr>
             <a:r>
-              <a:t>Guarantees 100% provenance verification</a:t>
-            </a:r>
-          </a:p>
-        </p:txBody>
-      </p:sp>
-    </p:spTree>
-  </p:cSld>
-  <p:clrMapOvr>
-    <a:masterClrMapping/>
-  </p:clrMapOvr>
-</p:sld>
-</file>
-
-<file path=ppt/slides/slide6.xml><?xml version="1.0" encoding="utf-8"?>
-<p:sld xmlns:a="http://schemas.openxmlformats.org/drawingml/2006/main" xmlns:p="http://schemas.openxmlformats.org/presentationml/2006/main" xmlns:r="http://schemas.openxmlformats.org/officeDocument/2006/relationships">
-  <p:cSld>
-    <p:spTree>
-      <p:nvGrpSpPr>
-        <p:cNvPr id="1" name=""/>
-        <p:cNvGrpSpPr/>
-        <p:nvPr/>
-      </p:nvGrpSpPr>
-      <p:grpSpPr/>
-      <p:sp>
-        <p:nvSpPr>
-          <p:cNvPr id="2" name="Title 1"/>
-          <p:cNvSpPr>
-            <a:spLocks noGrp="1"/>
-          </p:cNvSpPr>
-          <p:nvPr>
-            <p:ph type="title"/>
-          </p:nvPr>
-        </p:nvSpPr>
-        <p:spPr/>
-        <p:txBody>
-          <a:bodyPr/>
-          <a:lstStyle/>
-          <a:p>
-            <a:r>
-              <a:t>Conclusion</a:t>
-            </a:r>
-          </a:p>
-        </p:txBody>
-      </p:sp>
-      <p:sp>
-        <p:nvSpPr>
-          <p:cNvPr id="3" name="Content Placeholder 2"/>
-          <p:cNvSpPr>
-            <a:spLocks noGrp="1"/>
-          </p:cNvSpPr>
-          <p:nvPr>
-            <p:ph idx="1"/>
-          </p:nvPr>
-        </p:nvSpPr>
-        <p:spPr/>
-        <p:txBody>
-          <a:bodyPr/>
-          <a:lstStyle/>
-          <a:p/>
-          <a:p>
-            <a:pPr>
-              <a:defRPr sz="2200"/>
-            </a:pPr>
-            <a:r>
-              <a:t>AI-driven system delivering consistent, time-efficient, provenance-verified content</a:t>
+              <a:t>PRISM generates multiple content formats from a single source document, ensuring consistency and traceability.</a:t>
             </a:r>
           </a:p>
         </p:txBody>

</xml_diff>